<commit_message>
Move current model changes to AddRecovery branch
</commit_message>
<xml_diff>
--- a/Model schematic.pptx
+++ b/Model schematic.pptx
@@ -268,7 +268,7 @@
           <a:p>
             <a:fld id="{4ACD6CCD-50EB-0843-8C90-55A06B658EEA}" type="datetimeFigureOut">
               <a:rPr lang="en-US" smtClean="0"/>
-              <a:t>8/22/26</a:t>
+              <a:t>8/28/26</a:t>
             </a:fld>
             <a:endParaRPr lang="en-US"/>
           </a:p>
@@ -466,7 +466,7 @@
           <a:p>
             <a:fld id="{4ACD6CCD-50EB-0843-8C90-55A06B658EEA}" type="datetimeFigureOut">
               <a:rPr lang="en-US" smtClean="0"/>
-              <a:t>8/22/26</a:t>
+              <a:t>8/28/26</a:t>
             </a:fld>
             <a:endParaRPr lang="en-US"/>
           </a:p>
@@ -674,7 +674,7 @@
           <a:p>
             <a:fld id="{4ACD6CCD-50EB-0843-8C90-55A06B658EEA}" type="datetimeFigureOut">
               <a:rPr lang="en-US" smtClean="0"/>
-              <a:t>8/22/26</a:t>
+              <a:t>8/28/26</a:t>
             </a:fld>
             <a:endParaRPr lang="en-US"/>
           </a:p>
@@ -872,7 +872,7 @@
           <a:p>
             <a:fld id="{4ACD6CCD-50EB-0843-8C90-55A06B658EEA}" type="datetimeFigureOut">
               <a:rPr lang="en-US" smtClean="0"/>
-              <a:t>8/22/26</a:t>
+              <a:t>8/28/26</a:t>
             </a:fld>
             <a:endParaRPr lang="en-US"/>
           </a:p>
@@ -1147,7 +1147,7 @@
           <a:p>
             <a:fld id="{4ACD6CCD-50EB-0843-8C90-55A06B658EEA}" type="datetimeFigureOut">
               <a:rPr lang="en-US" smtClean="0"/>
-              <a:t>8/22/26</a:t>
+              <a:t>8/28/26</a:t>
             </a:fld>
             <a:endParaRPr lang="en-US"/>
           </a:p>
@@ -1412,7 +1412,7 @@
           <a:p>
             <a:fld id="{4ACD6CCD-50EB-0843-8C90-55A06B658EEA}" type="datetimeFigureOut">
               <a:rPr lang="en-US" smtClean="0"/>
-              <a:t>8/22/26</a:t>
+              <a:t>8/28/26</a:t>
             </a:fld>
             <a:endParaRPr lang="en-US"/>
           </a:p>
@@ -1824,7 +1824,7 @@
           <a:p>
             <a:fld id="{4ACD6CCD-50EB-0843-8C90-55A06B658EEA}" type="datetimeFigureOut">
               <a:rPr lang="en-US" smtClean="0"/>
-              <a:t>8/22/26</a:t>
+              <a:t>8/28/26</a:t>
             </a:fld>
             <a:endParaRPr lang="en-US"/>
           </a:p>
@@ -1965,7 +1965,7 @@
           <a:p>
             <a:fld id="{4ACD6CCD-50EB-0843-8C90-55A06B658EEA}" type="datetimeFigureOut">
               <a:rPr lang="en-US" smtClean="0"/>
-              <a:t>8/22/26</a:t>
+              <a:t>8/28/26</a:t>
             </a:fld>
             <a:endParaRPr lang="en-US"/>
           </a:p>
@@ -2078,7 +2078,7 @@
           <a:p>
             <a:fld id="{4ACD6CCD-50EB-0843-8C90-55A06B658EEA}" type="datetimeFigureOut">
               <a:rPr lang="en-US" smtClean="0"/>
-              <a:t>8/22/26</a:t>
+              <a:t>8/28/26</a:t>
             </a:fld>
             <a:endParaRPr lang="en-US"/>
           </a:p>
@@ -2389,7 +2389,7 @@
           <a:p>
             <a:fld id="{4ACD6CCD-50EB-0843-8C90-55A06B658EEA}" type="datetimeFigureOut">
               <a:rPr lang="en-US" smtClean="0"/>
-              <a:t>8/22/26</a:t>
+              <a:t>8/28/26</a:t>
             </a:fld>
             <a:endParaRPr lang="en-US"/>
           </a:p>
@@ -2677,7 +2677,7 @@
           <a:p>
             <a:fld id="{4ACD6CCD-50EB-0843-8C90-55A06B658EEA}" type="datetimeFigureOut">
               <a:rPr lang="en-US" smtClean="0"/>
-              <a:t>8/22/26</a:t>
+              <a:t>8/28/26</a:t>
             </a:fld>
             <a:endParaRPr lang="en-US"/>
           </a:p>
@@ -2918,7 +2918,7 @@
           <a:p>
             <a:fld id="{4ACD6CCD-50EB-0843-8C90-55A06B658EEA}" type="datetimeFigureOut">
               <a:rPr lang="en-US" smtClean="0"/>
-              <a:t>8/22/26</a:t>
+              <a:t>8/28/26</a:t>
             </a:fld>
             <a:endParaRPr lang="en-US"/>
           </a:p>
@@ -3904,8 +3904,8 @@
           </a:fontRef>
         </p:style>
       </p:cxnSp>
-      <mc:AlternateContent xmlns:mc="http://schemas.openxmlformats.org/markup-compatibility/2006">
-        <mc:Choice xmlns:a14="http://schemas.microsoft.com/office/drawing/2010/main" Requires="a14">
+      <mc:AlternateContent xmlns:mc="http://schemas.openxmlformats.org/markup-compatibility/2006" xmlns:a14="http://schemas.microsoft.com/office/drawing/2010/main">
+        <mc:Choice Requires="a14">
           <p:sp>
             <p:nvSpPr>
               <p:cNvPr id="71" name="TextBox 70">
@@ -3974,7 +3974,7 @@
             </p:txBody>
           </p:sp>
         </mc:Choice>
-        <mc:Fallback>
+        <mc:Fallback xmlns="">
           <p:sp>
             <p:nvSpPr>
               <p:cNvPr id="71" name="TextBox 70">
@@ -4063,8 +4063,8 @@
           </a:fontRef>
         </p:style>
       </p:cxnSp>
-      <mc:AlternateContent xmlns:mc="http://schemas.openxmlformats.org/markup-compatibility/2006">
-        <mc:Choice xmlns:a14="http://schemas.microsoft.com/office/drawing/2010/main" Requires="a14">
+      <mc:AlternateContent xmlns:mc="http://schemas.openxmlformats.org/markup-compatibility/2006" xmlns:a14="http://schemas.microsoft.com/office/drawing/2010/main">
+        <mc:Choice Requires="a14">
           <p:sp>
             <p:nvSpPr>
               <p:cNvPr id="73" name="TextBox 72">
@@ -4133,7 +4133,7 @@
             </p:txBody>
           </p:sp>
         </mc:Choice>
-        <mc:Fallback>
+        <mc:Fallback xmlns="">
           <p:sp>
             <p:nvSpPr>
               <p:cNvPr id="73" name="TextBox 72">
@@ -4585,8 +4585,8 @@
             </a:fontRef>
           </p:style>
         </p:cxnSp>
-        <mc:AlternateContent xmlns:mc="http://schemas.openxmlformats.org/markup-compatibility/2006">
-          <mc:Choice xmlns:a14="http://schemas.microsoft.com/office/drawing/2010/main" Requires="a14">
+        <mc:AlternateContent xmlns:mc="http://schemas.openxmlformats.org/markup-compatibility/2006" xmlns:a14="http://schemas.microsoft.com/office/drawing/2010/main">
+          <mc:Choice Requires="a14">
             <p:sp>
               <p:nvSpPr>
                 <p:cNvPr id="40" name="TextBox 39">
@@ -4673,7 +4673,7 @@
               </p:txBody>
             </p:sp>
           </mc:Choice>
-          <mc:Fallback>
+          <mc:Fallback xmlns="">
             <p:sp>
               <p:nvSpPr>
                 <p:cNvPr id="40" name="TextBox 39">
@@ -4718,8 +4718,8 @@
             </p:sp>
           </mc:Fallback>
         </mc:AlternateContent>
-        <mc:AlternateContent xmlns:mc="http://schemas.openxmlformats.org/markup-compatibility/2006">
-          <mc:Choice xmlns:a14="http://schemas.microsoft.com/office/drawing/2010/main" Requires="a14">
+        <mc:AlternateContent xmlns:mc="http://schemas.openxmlformats.org/markup-compatibility/2006" xmlns:a14="http://schemas.microsoft.com/office/drawing/2010/main">
+          <mc:Choice Requires="a14">
             <p:sp>
               <p:nvSpPr>
                 <p:cNvPr id="42" name="TextBox 41">
@@ -4794,7 +4794,7 @@
               </p:txBody>
             </p:sp>
           </mc:Choice>
-          <mc:Fallback>
+          <mc:Fallback xmlns="">
             <p:sp>
               <p:nvSpPr>
                 <p:cNvPr id="42" name="TextBox 41">
@@ -4839,8 +4839,8 @@
             </p:sp>
           </mc:Fallback>
         </mc:AlternateContent>
-        <mc:AlternateContent xmlns:mc="http://schemas.openxmlformats.org/markup-compatibility/2006">
-          <mc:Choice xmlns:a14="http://schemas.microsoft.com/office/drawing/2010/main" Requires="a14">
+        <mc:AlternateContent xmlns:mc="http://schemas.openxmlformats.org/markup-compatibility/2006" xmlns:a14="http://schemas.microsoft.com/office/drawing/2010/main">
+          <mc:Choice Requires="a14">
             <p:sp>
               <p:nvSpPr>
                 <p:cNvPr id="43" name="TextBox 42">
@@ -4915,7 +4915,7 @@
               </p:txBody>
             </p:sp>
           </mc:Choice>
-          <mc:Fallback>
+          <mc:Fallback xmlns="">
             <p:sp>
               <p:nvSpPr>
                 <p:cNvPr id="43" name="TextBox 42">
@@ -5003,8 +5003,8 @@
             </a:fontRef>
           </p:style>
         </p:cxnSp>
-        <mc:AlternateContent xmlns:mc="http://schemas.openxmlformats.org/markup-compatibility/2006">
-          <mc:Choice xmlns:a14="http://schemas.microsoft.com/office/drawing/2010/main" Requires="a14">
+        <mc:AlternateContent xmlns:mc="http://schemas.openxmlformats.org/markup-compatibility/2006" xmlns:a14="http://schemas.microsoft.com/office/drawing/2010/main">
+          <mc:Choice Requires="a14">
             <p:sp>
               <p:nvSpPr>
                 <p:cNvPr id="85" name="TextBox 84">
@@ -5104,7 +5104,7 @@
               </p:txBody>
             </p:sp>
           </mc:Choice>
-          <mc:Fallback>
+          <mc:Fallback xmlns="">
             <p:sp>
               <p:nvSpPr>
                 <p:cNvPr id="85" name="TextBox 84">
@@ -5149,8 +5149,8 @@
             </p:sp>
           </mc:Fallback>
         </mc:AlternateContent>
-        <mc:AlternateContent xmlns:mc="http://schemas.openxmlformats.org/markup-compatibility/2006">
-          <mc:Choice xmlns:a14="http://schemas.microsoft.com/office/drawing/2010/main" Requires="a14">
+        <mc:AlternateContent xmlns:mc="http://schemas.openxmlformats.org/markup-compatibility/2006" xmlns:a14="http://schemas.microsoft.com/office/drawing/2010/main">
+          <mc:Choice Requires="a14">
             <p:sp>
               <p:nvSpPr>
                 <p:cNvPr id="86" name="TextBox 85">
@@ -5262,7 +5262,7 @@
               </p:txBody>
             </p:sp>
           </mc:Choice>
-          <mc:Fallback>
+          <mc:Fallback xmlns="">
             <p:sp>
               <p:nvSpPr>
                 <p:cNvPr id="86" name="TextBox 85">
@@ -6775,8 +6775,8 @@
             </a:p>
           </p:txBody>
         </p:sp>
-        <mc:AlternateContent xmlns:mc="http://schemas.openxmlformats.org/markup-compatibility/2006">
-          <mc:Choice xmlns:a14="http://schemas.microsoft.com/office/drawing/2010/main" Requires="a14">
+        <mc:AlternateContent xmlns:mc="http://schemas.openxmlformats.org/markup-compatibility/2006" xmlns:a14="http://schemas.microsoft.com/office/drawing/2010/main">
+          <mc:Choice Requires="a14">
             <p:sp>
               <p:nvSpPr>
                 <p:cNvPr id="51" name="TextBox 50">
@@ -6875,7 +6875,7 @@
               </p:txBody>
             </p:sp>
           </mc:Choice>
-          <mc:Fallback>
+          <mc:Fallback xmlns="">
             <p:sp>
               <p:nvSpPr>
                 <p:cNvPr id="51" name="TextBox 50">
@@ -7008,8 +7008,8 @@
             </a:fontRef>
           </p:style>
         </p:cxnSp>
-        <mc:AlternateContent xmlns:mc="http://schemas.openxmlformats.org/markup-compatibility/2006">
-          <mc:Choice xmlns:a14="http://schemas.microsoft.com/office/drawing/2010/main" Requires="a14">
+        <mc:AlternateContent xmlns:mc="http://schemas.openxmlformats.org/markup-compatibility/2006" xmlns:a14="http://schemas.microsoft.com/office/drawing/2010/main">
+          <mc:Choice Requires="a14">
             <p:sp>
               <p:nvSpPr>
                 <p:cNvPr id="128" name="TextBox 127">
@@ -7090,7 +7090,7 @@
               </p:txBody>
             </p:sp>
           </mc:Choice>
-          <mc:Fallback>
+          <mc:Fallback xmlns="">
             <p:sp>
               <p:nvSpPr>
                 <p:cNvPr id="128" name="TextBox 127">
@@ -7135,8 +7135,8 @@
             </p:sp>
           </mc:Fallback>
         </mc:AlternateContent>
-        <mc:AlternateContent xmlns:mc="http://schemas.openxmlformats.org/markup-compatibility/2006">
-          <mc:Choice xmlns:a14="http://schemas.microsoft.com/office/drawing/2010/main" Requires="a14">
+        <mc:AlternateContent xmlns:mc="http://schemas.openxmlformats.org/markup-compatibility/2006" xmlns:a14="http://schemas.microsoft.com/office/drawing/2010/main">
+          <mc:Choice Requires="a14">
             <p:sp>
               <p:nvSpPr>
                 <p:cNvPr id="129" name="TextBox 128">
@@ -7229,7 +7229,7 @@
               </p:txBody>
             </p:sp>
           </mc:Choice>
-          <mc:Fallback>
+          <mc:Fallback xmlns="">
             <p:sp>
               <p:nvSpPr>
                 <p:cNvPr id="129" name="TextBox 128">
@@ -7274,8 +7274,8 @@
             </p:sp>
           </mc:Fallback>
         </mc:AlternateContent>
-        <mc:AlternateContent xmlns:mc="http://schemas.openxmlformats.org/markup-compatibility/2006">
-          <mc:Choice xmlns:a14="http://schemas.microsoft.com/office/drawing/2010/main" Requires="a14">
+        <mc:AlternateContent xmlns:mc="http://schemas.openxmlformats.org/markup-compatibility/2006" xmlns:a14="http://schemas.microsoft.com/office/drawing/2010/main">
+          <mc:Choice Requires="a14">
             <p:sp>
               <p:nvSpPr>
                 <p:cNvPr id="141" name="TextBox 140">
@@ -7350,7 +7350,7 @@
               </p:txBody>
             </p:sp>
           </mc:Choice>
-          <mc:Fallback>
+          <mc:Fallback xmlns="">
             <p:sp>
               <p:nvSpPr>
                 <p:cNvPr id="141" name="TextBox 140">
@@ -7395,8 +7395,8 @@
             </p:sp>
           </mc:Fallback>
         </mc:AlternateContent>
-        <mc:AlternateContent xmlns:mc="http://schemas.openxmlformats.org/markup-compatibility/2006">
-          <mc:Choice xmlns:a14="http://schemas.microsoft.com/office/drawing/2010/main" Requires="a14">
+        <mc:AlternateContent xmlns:mc="http://schemas.openxmlformats.org/markup-compatibility/2006" xmlns:a14="http://schemas.microsoft.com/office/drawing/2010/main">
+          <mc:Choice Requires="a14">
             <p:sp>
               <p:nvSpPr>
                 <p:cNvPr id="142" name="TextBox 141">
@@ -7465,7 +7465,7 @@
               </p:txBody>
             </p:sp>
           </mc:Choice>
-          <mc:Fallback>
+          <mc:Fallback xmlns="">
             <p:sp>
               <p:nvSpPr>
                 <p:cNvPr id="142" name="TextBox 141">
@@ -14516,7 +14516,7 @@
                 <a:p>
                   <a:pPr algn="ctr"/>
                   <a:r>
-                    <a:rPr lang="en-US" dirty="0">
+                    <a:rPr lang="en-US" sz="1200" dirty="0">
                       <a:solidFill>
                         <a:sysClr val="windowText" lastClr="000000"/>
                       </a:solidFill>
@@ -14527,12 +14527,12 @@
                 <a:p>
                   <a:pPr algn="ctr"/>
                   <a:r>
-                    <a:rPr lang="en-US" dirty="0">
+                    <a:rPr lang="en-US" sz="1200" dirty="0">
                       <a:solidFill>
                         <a:sysClr val="windowText" lastClr="000000"/>
                       </a:solidFill>
                     </a:rPr>
-                    <a:t>Top 20%?</a:t>
+                    <a:t>thresholds met?</a:t>
                   </a:r>
                 </a:p>
               </p:txBody>
@@ -14654,7 +14654,7 @@
                 <a:p>
                   <a:pPr algn="ctr"/>
                   <a:r>
-                    <a:rPr lang="en-US" dirty="0">
+                    <a:rPr lang="en-US" sz="1200" dirty="0">
                       <a:solidFill>
                         <a:sysClr val="windowText" lastClr="000000"/>
                       </a:solidFill>
@@ -14665,12 +14665,12 @@
                 <a:p>
                   <a:pPr algn="ctr"/>
                   <a:r>
-                    <a:rPr lang="en-US" dirty="0">
+                    <a:rPr lang="en-US" sz="1200" dirty="0">
                       <a:solidFill>
                         <a:sysClr val="windowText" lastClr="000000"/>
                       </a:solidFill>
                     </a:rPr>
-                    <a:t>Top 20%?</a:t>
+                    <a:t>thresholds met?</a:t>
                   </a:r>
                 </a:p>
               </p:txBody>

</xml_diff>